<commit_message>
Welt 2: Tracetabellen nur mit Variablen, Codestellen markiert
AB 1 (A1, A4) + LSG, AB 2 (Infoteile, A2), AB 3 (A5, Infoteil 2) + LSG, Folien 10–12/19/20,
Warm-up W2-05/06/08/14, Lab W2-L1-03, W2-L1-06, W2-L2-05.

Co-Authored-By: Claude Opus 5.5 <noreply@anthropic.com>
Claude-Session: https://claude.ai/code/session_01CemoEYGRdCe5FszEBVFFUP
</commit_message>
<xml_diff>
--- a/materialien/Welt2_Rangliste/1_Praesentation/AQ_W2_Rangliste.pptx
+++ b/materialien/Welt2_Rangliste/1_Praesentation/AQ_W2_Rangliste.pptx
@@ -1059,7 +1059,7 @@
           <a:p>
             <a:r>
               <a:rPr lang="en-US" dirty="0"/>
-              <a:t>Selectionsort, DS 14 (ca. 6 min): Zustände nach jedem Durchlauf der äußeren Schleife – genau das Format der Tracetabelle im Abitur. Gezählt: V = Aufrufe von besser, T = Aufrufe von vertausche, jeweils kumuliert (mit der Musterlösung ausgeführt). In den Durchläufen i = 1 und i = 3 steht das Maximum schon an Position i, deshalb wird nicht getauscht. Nach i = 3 ist auch der letzte Eintrag automatisch richtig. Kernaussage: Die Zahl der Vergleiche hängt nicht von den Daten ab, die der Vertauschungen schon. Selectionsort ist nicht stabil (Thema auf dem AB).</a:t>
+              <a:t>Selectionsort, DS 14 (ca. 6 min): Zustände nach jedem Durchlauf der äußeren Schleife – genau das Format der Tracetabelle im Abitur. Jede Zeile entsteht an der im Code mit „// → Tabellenzeile“ markierten Stelle (Ende des Durchlaufs, gilt ebenso für Insertion- und Bubblesort). Gezählt: V = Aufrufe von besser, T = Aufrufe von vertausche, jeweils kumuliert (mit der Musterlösung ausgeführt). In den Durchläufen i = 1 und i = 3 steht das Maximum schon an Position i, deshalb wird nicht getauscht. Nach i = 3 ist auch der letzte Eintrag automatisch richtig. Kernaussage: Die Zahl der Vergleiche hängt nicht von den Daten ab, die der Vertauschungen schon. Selectionsort ist nicht stabil (Thema auf dem AB).</a:t>
             </a:r>
             <a:endParaRPr lang="en-US" dirty="0"/>
           </a:p>
@@ -2027,7 +2027,7 @@
           <a:p>
             <a:r>
               <a:rPr lang="en-US" dirty="0"/>
-              <a:t>Trace der binären Suche, DS 16 (ca. 8 min): Grau = außerhalb von lo … hi, also bereits ausgeschlossen; Gold = mid. Die Suche nach 67 endet nach 3 Durchläufen mit Index 10, die Suche nach 30 nach 4 Durchläufen mit −1 (beides mit Suche.binaer der Musterlösung ausgeführt). Die Tracetabelle unten ist das Abi-Format: pro Durchlauf eine Zeile mit lo, hi, mid und r[mid]. Erst selbst auf Papier ausfüllen lassen, dann aufdecken. Warm-up-Karten Welt 2 enthalten weitere Traces.</a:t>
+              <a:t>Trace der binären Suche, DS 16 (ca. 8 min): Grau = außerhalb von lo … hi, also bereits ausgeschlossen; Gold = mid. Die Suche nach 67 endet nach 3 Durchläufen mit Index 10, die Suche nach 30 nach 4 Durchläufen mit −1 (beides mit Suche.binaer der Musterlösung ausgeführt). Die Tracetabelle unten ist das Abi-Format: pro Durchlauf eine Zeile mit lo, hi, mid und r[mid] – eingetragen an der auf Folie 19 mit „// → Tabellenzeile“ markierten Stelle (sobald mid berechnet ist). Bedingungen bekommen keine eigene Spalte; unter „Aktion“ steht nur, was danach geschieht. Erst selbst auf Papier ausfüllen lassen, dann aufdecken. Warm-up-Karten Welt 2 enthalten weitere Traces.</a:t>
             </a:r>
             <a:endParaRPr lang="en-US" dirty="0"/>
           </a:p>
@@ -5838,6 +5838,17 @@
               </a:rPr>
               <a:t>        }</a:t>
             </a:r>
+            <a:r>
+              <a:rPr lang="en-US" sz="1300" dirty="0">
+                <a:solidFill>
+                  <a:srgbClr val="5F7F5F"/>
+                </a:solidFill>
+                <a:latin typeface="Consolas" pitchFamily="34" charset="0"/>
+                <a:ea typeface="Consolas" pitchFamily="34" charset="-122"/>
+                <a:cs typeface="Consolas" pitchFamily="34" charset="-120"/>
+              </a:rPr>
+              <a:t>   // → Tabellenzeile</a:t>
+            </a:r>
             <a:endParaRPr lang="en-US" sz="1300" dirty="0"/>
           </a:p>
           <a:p>
@@ -8910,6 +8921,17 @@
               </a:rPr>
               <a:t>        }</a:t>
             </a:r>
+            <a:r>
+              <a:rPr lang="en-US" sz="1400" dirty="0">
+                <a:solidFill>
+                  <a:srgbClr val="5F7F5F"/>
+                </a:solidFill>
+                <a:latin typeface="Consolas" pitchFamily="34" charset="0"/>
+                <a:ea typeface="Consolas" pitchFamily="34" charset="-122"/>
+                <a:cs typeface="Consolas" pitchFamily="34" charset="-120"/>
+              </a:rPr>
+              <a:t>   // → Tabellenzeile</a:t>
+            </a:r>
             <a:endParaRPr lang="en-US" sz="1400" dirty="0"/>
           </a:p>
           <a:p>
@@ -11372,6 +11394,17 @@
               </a:rPr>
               <a:t> = 0;</a:t>
             </a:r>
+            <a:r>
+              <a:rPr lang="en-US" sz="1200" dirty="0">
+                <a:solidFill>
+                  <a:srgbClr val="5F7F5F"/>
+                </a:solidFill>
+                <a:latin typeface="Consolas" pitchFamily="34" charset="0"/>
+                <a:ea typeface="Consolas" pitchFamily="34" charset="-122"/>
+                <a:cs typeface="Consolas" pitchFamily="34" charset="-120"/>
+              </a:rPr>
+              <a:t>   // → Tabellenzeile (Startwerte)</a:t>
+            </a:r>
             <a:endParaRPr lang="en-US" sz="1200" dirty="0"/>
           </a:p>
           <a:p>
@@ -12333,6 +12366,17 @@
                 <a:cs typeface="Consolas" pitchFamily="34" charset="-120"/>
               </a:rPr>
               <a:t>++;</a:t>
+            </a:r>
+            <a:r>
+              <a:rPr lang="en-US" sz="1200" dirty="0">
+                <a:solidFill>
+                  <a:srgbClr val="5F7F5F"/>
+                </a:solidFill>
+                <a:latin typeface="Consolas" pitchFamily="34" charset="0"/>
+                <a:ea typeface="Consolas" pitchFamily="34" charset="-122"/>
+                <a:cs typeface="Consolas" pitchFamily="34" charset="-120"/>
+              </a:rPr>
+              <a:t>   // → Tabellenzeile</a:t>
             </a:r>
             <a:endParaRPr lang="en-US" sz="1200" dirty="0"/>
           </a:p>
@@ -29463,6 +29507,17 @@
               </a:rPr>
               <a:t>) / 2;</a:t>
             </a:r>
+            <a:r>
+              <a:rPr lang="en-US" sz="1000" dirty="0">
+                <a:solidFill>
+                  <a:srgbClr val="5F7F5F"/>
+                </a:solidFill>
+                <a:latin typeface="Consolas" pitchFamily="34" charset="0"/>
+                <a:ea typeface="Consolas" pitchFamily="34" charset="-122"/>
+                <a:cs typeface="Consolas" pitchFamily="34" charset="-120"/>
+              </a:rPr>
+              <a:t>  // → Tabellenzeile</a:t>
+            </a:r>
             <a:endParaRPr lang="en-US" sz="1400" dirty="0"/>
           </a:p>
           <a:p>
@@ -34730,7 +34785,7 @@
                           <a:ea typeface="Calibri" pitchFamily="34" charset="-122"/>
                           <a:cs typeface="Calibri" pitchFamily="34" charset="-120"/>
                         </a:rPr>
-                        <a:t>Entscheidung</a:t>
+                        <a:t>Aktion</a:t>
                       </a:r>
                       <a:endParaRPr lang="en-US" sz="1500" dirty="0">
                         <a:latin typeface="Calibri" charset="0"/>
@@ -35125,7 +35180,7 @@
                           <a:ea typeface="Calibri" pitchFamily="34" charset="-122"/>
                           <a:cs typeface="Calibri" pitchFamily="34" charset="-120"/>
                         </a:rPr>
-                        <a:t>33 &gt; 30 → hi = 4</a:t>
+                        <a:t>hi ← 4</a:t>
                       </a:r>
                       <a:endParaRPr lang="en-US" sz="1500" dirty="0">
                         <a:latin typeface="Calibri" charset="0"/>
@@ -35517,7 +35572,7 @@
                           <a:ea typeface="Calibri" pitchFamily="34" charset="-122"/>
                           <a:cs typeface="Calibri" pitchFamily="34" charset="-120"/>
                         </a:rPr>
-                        <a:t>15 &lt; 30 → lo = 3</a:t>
+                        <a:t>lo ← 3</a:t>
                       </a:r>
                       <a:endParaRPr lang="en-US" sz="1500" dirty="0">
                         <a:latin typeface="Calibri" charset="0"/>
@@ -35909,7 +35964,7 @@
                           <a:ea typeface="Calibri" pitchFamily="34" charset="-122"/>
                           <a:cs typeface="Calibri" pitchFamily="34" charset="-120"/>
                         </a:rPr>
-                        <a:t>21 &lt; 30 → lo = 4</a:t>
+                        <a:t>lo ← 4</a:t>
                       </a:r>
                       <a:endParaRPr lang="en-US" sz="1500" dirty="0">
                         <a:latin typeface="Calibri" charset="0"/>
@@ -36301,7 +36356,7 @@
                           <a:ea typeface="Calibri" pitchFamily="34" charset="-122"/>
                           <a:cs typeface="Calibri" pitchFamily="34" charset="-120"/>
                         </a:rPr>
-                        <a:t>26 &lt; 30 → lo = 5</a:t>
+                        <a:t>lo ← 5</a:t>
                       </a:r>
                       <a:endParaRPr lang="en-US" sz="1500" dirty="0">
                         <a:latin typeface="Calibri" charset="0"/>

</xml_diff>